<commit_message>
- SRAM Memory Bank Switching Including:     - Updated BIOS     - Updated KiCad Schema - Remove Ctrl+s and print from CPM - Cleaned up docs - Z80 IO and IRQ Optimizations
</commit_message>
<xml_diff>
--- a/docs/Z80-ROMless-SBC-Design-Overview.pptx
+++ b/docs/Z80-ROMless-SBC-Design-Overview.pptx
@@ -1722,7 +1722,7 @@
                 <a:ea typeface="Arial" pitchFamily="34" charset="-122"/>
                 <a:cs typeface="Arial" pitchFamily="34" charset="-120"/>
               </a:rPr>
-              <a:t>PIO0: I²C matrix display</a:t>
+              <a:t>PIO0 matrix; PIO1 bank select</a:t>
             </a:r>
             <a:endParaRPr lang="en-US" sz="1800" dirty="0"/>
           </a:p>
@@ -1980,7 +1980,7 @@
                 <a:ea typeface="Arial" pitchFamily="34" charset="-122"/>
                 <a:cs typeface="Arial" pitchFamily="34" charset="-120"/>
               </a:rPr>
-              <a:t>64 KiB SRAM</a:t>
+              <a:t>128 KiB SRAM</a:t>
             </a:r>
             <a:endParaRPr lang="en-US" sz="2500" dirty="0"/>
           </a:p>
@@ -2019,7 +2019,7 @@
                 <a:ea typeface="Arial" pitchFamily="34" charset="-122"/>
                 <a:cs typeface="Arial" pitchFamily="34" charset="-120"/>
               </a:rPr>
-              <a:t>Code, operating system and data</a:t>
+              <a:t>2 banks; 64 KiB Z80 window</a:t>
             </a:r>
             <a:endParaRPr lang="en-US" sz="1800" dirty="0"/>
           </a:p>
@@ -2616,7 +2616,7 @@
                 <a:ea typeface="Arial" pitchFamily="34" charset="-122"/>
                 <a:cs typeface="Arial" pitchFamily="34" charset="-120"/>
               </a:rPr>
-              <a:t>64 KiB SRAM address space</a:t>
+              <a:t>128 KiB SRAM; two 64 KiB banks</a:t>
             </a:r>
             <a:endParaRPr lang="en-US" sz="1800" dirty="0"/>
           </a:p>
@@ -2639,7 +2639,7 @@
                 <a:ea typeface="Arial" pitchFamily="34" charset="-122"/>
                 <a:cs typeface="Arial" pitchFamily="34" charset="-120"/>
               </a:rPr>
-              <a:t>Z80 alone drives memory addresses and writes SRAM, even during boot.</a:t>
+              <a:t>GP8→U4 selects SRAM A16; Z80 owns A0-A15 and all writes.</a:t>
             </a:r>
             <a:endParaRPr lang="en-US" sz="1800" dirty="0"/>
           </a:p>
@@ -3055,7 +3055,7 @@
                 <a:ea typeface="Arial" pitchFamily="34" charset="-122"/>
                 <a:cs typeface="Arial" pitchFamily="34" charset="-120"/>
               </a:rPr>
-              <a:t>Pico PWM  →  AHCT244 level buffer  →  Z80 CLK: 20 MHz nominal</a:t>
+              <a:t>Pico PWM / PIO1  →  AHCT244 level buffer  →  Z80 CLK: 20 MHz nominal</a:t>
             </a:r>
             <a:endParaRPr lang="en-US" sz="2300" dirty="0"/>
           </a:p>
@@ -3500,7 +3500,7 @@
                 <a:ea typeface="Arial" pitchFamily="34" charset="-122"/>
                 <a:cs typeface="Arial" pitchFamily="34" charset="-120"/>
               </a:rPr>
-              <a:t>I/O traps and port adapters</a:t>
+              <a:t>I/O traps and PIO1 bank select</a:t>
             </a:r>
             <a:endParaRPr lang="en-US" sz="1800" dirty="0"/>
           </a:p>
@@ -5826,7 +5826,7 @@
                 <a:ea typeface="Arial" pitchFamily="34" charset="-122"/>
                 <a:cs typeface="Arial" pitchFamily="34" charset="-120"/>
               </a:rPr>
-              <a:t>The Z80 runs from SRAM until an IN or OUT instruction needs a Pico-managed peripheral.</a:t>
+              <a:t>The Z80 runs directly from SRAM. PIO1 handles bank-select OUT 07h at hardware speed.</a:t>
             </a:r>
             <a:endParaRPr lang="en-US" sz="1800" dirty="0"/>
           </a:p>
@@ -6123,7 +6123,7 @@
                 <a:ea typeface="Arial" pitchFamily="34" charset="-122"/>
                 <a:cs typeface="Arial" pitchFamily="34" charset="-120"/>
               </a:rPr>
-              <a:t>Core-0 I/O trap</a:t>
+              <a:t>Bank select + I/O traps</a:t>
             </a:r>
             <a:endParaRPr lang="en-US" sz="2500" dirty="0"/>
           </a:p>
@@ -7454,7 +7454,7 @@
                 <a:ea typeface="Arial" pitchFamily="34" charset="-122"/>
                 <a:cs typeface="Arial" pitchFamily="34" charset="-120"/>
               </a:rPr>
-              <a:t>The Pico injects instructions, verifies SRAM, then supplies the 20 MHz clock.</a:t>
+              <a:t>The Pico loads and verifies SRAM. PIO1 selects either 64 KiB bank without changing the 20 MHz clock.</a:t>
             </a:r>
             <a:endParaRPr lang="en-US" sz="1800" dirty="0"/>
           </a:p>
@@ -8011,7 +8011,7 @@
               </a:defRPr>
             </a:pPr>
             <a:r>
-              <a:t>Clocks and resets the CPU; traps I/O and injects/verifies the SRAM image.</a:t>
+              <a:t>Clocks/resets CPU; PIO1 bank switch; injects/verifies SRAM.</a:t>
             </a:r>
           </a:p>
         </p:txBody>
@@ -8119,7 +8119,7 @@
               </a:defRPr>
             </a:pPr>
             <a:r>
-              <a:t>Owns USB, Wi-Fi, flash disks, services and PIO I²C display.</a:t>
+              <a:t>Owns USB, Wi-Fi, flash disks, services and PIO0 I²C display.</a:t>
             </a:r>
           </a:p>
         </p:txBody>
@@ -9035,7 +9035,7 @@
               </a:defRPr>
             </a:pPr>
             <a:r>
-              <a:t>64 KiB address space</a:t>
+              <a:t>Two 64 KiB banks</a:t>
             </a:r>
           </a:p>
         </p:txBody>
@@ -9071,7 +9071,7 @@
               </a:defRPr>
             </a:pPr>
             <a:r>
-              <a:t>A16 is tied LOW, so only the lower 64 KiB is used.</a:t>
+              <a:t>PIO1: GP8→U4→A16; R24 pulls GP8 LOW at startup.</a:t>
             </a:r>
           </a:p>
         </p:txBody>
@@ -9179,7 +9179,7 @@
               </a:defRPr>
             </a:pPr>
             <a:r>
-              <a:t>Holds the running code, CP/M and working data; no ROM is fitted.</a:t>
+              <a:t>Z80 sees one 64 KiB window; OUT 07h selects the other bank.</a:t>
             </a:r>
           </a:p>
         </p:txBody>
@@ -10468,7 +10468,7 @@
               </a:defRPr>
             </a:pPr>
             <a:r>
-              <a:t>Buffers MREQ#, WR# and RD# so SRAM CMOS control inputs receive valid levels.</a:t>
+              <a:t>Buffers memory controls and level-shifts GP8 bank select to SRAM A16.</a:t>
             </a:r>
           </a:p>
         </p:txBody>

</xml_diff>